<commit_message>
Actualización de documentación, RPA y Bimestre 1
</commit_message>
<xml_diff>
--- a/documentacion/presentaciones/Presentacion_final.pptx
+++ b/documentacion/presentaciones/Presentacion_final.pptx
@@ -8234,13 +8234,52 @@
       </p:sp>
       <p:sp>
         <p:nvSpPr>
-          <p:cNvPr id="9" name="Shape 7"/>
-          <p:cNvSpPr/>
-          <p:nvPr/>
-        </p:nvSpPr>
-        <p:spPr>
-          <a:xfrm>
-            <a:off x="3429000" y="1600200"/>
+          <p:cNvPr id="11" name="Text 9"/>
+          <p:cNvSpPr/>
+          <p:nvPr/>
+        </p:nvSpPr>
+        <p:spPr>
+          <a:xfrm>
+            <a:off x="3630168" y="1810512"/>
+            <a:ext cx="457200" cy="457200"/>
+          </a:xfrm>
+          <a:prstGeom prst="rect">
+            <a:avLst/>
+          </a:prstGeom>
+          <a:noFill/>
+          <a:ln/>
+        </p:spPr>
+        <p:txBody>
+          <a:bodyPr wrap="square" rtlCol="0" anchor="ctr"/>
+          <a:lstStyle/>
+          <a:p>
+            <a:pPr marL="0" indent="0" algn="ctr">
+              <a:buNone/>
+            </a:pPr>
+            <a:r>
+              <a:rPr lang="en-US" sz="1600" b="1" dirty="0">
+                <a:solidFill>
+                  <a:srgbClr val="1E2761"/>
+                </a:solidFill>
+                <a:latin typeface="Calibri" pitchFamily="34" charset="0"/>
+                <a:ea typeface="Calibri" pitchFamily="34" charset="-122"/>
+                <a:cs typeface="Calibri" pitchFamily="34" charset="-120"/>
+              </a:rPr>
+              <a:t>2</a:t>
+            </a:r>
+            <a:endParaRPr lang="en-US" sz="1600" dirty="0"/>
+          </a:p>
+        </p:txBody>
+      </p:sp>
+      <p:sp>
+        <p:nvSpPr>
+          <p:cNvPr id="14" name="Shape 12"/>
+          <p:cNvSpPr/>
+          <p:nvPr/>
+        </p:nvSpPr>
+        <p:spPr>
+          <a:xfrm>
+            <a:off x="4160520" y="1600200"/>
             <a:ext cx="2697480" cy="2651760"/>
           </a:xfrm>
           <a:prstGeom prst="roundRect">
@@ -8261,13 +8300,13 @@
       </p:sp>
       <p:sp>
         <p:nvSpPr>
-          <p:cNvPr id="10" name="Shape 8"/>
-          <p:cNvSpPr/>
-          <p:nvPr/>
-        </p:nvSpPr>
-        <p:spPr>
-          <a:xfrm>
-            <a:off x="3630168" y="1810512"/>
+          <p:cNvPr id="15" name="Shape 13"/>
+          <p:cNvSpPr/>
+          <p:nvPr/>
+        </p:nvSpPr>
+        <p:spPr>
+          <a:xfrm>
+            <a:off x="4361688" y="1810512"/>
             <a:ext cx="457200" cy="457200"/>
           </a:xfrm>
           <a:prstGeom prst="roundRect">
@@ -8280,16 +8319,23 @@
           </a:solidFill>
           <a:ln/>
         </p:spPr>
-      </p:sp>
-      <p:sp>
-        <p:nvSpPr>
-          <p:cNvPr id="11" name="Text 9"/>
-          <p:cNvSpPr/>
-          <p:nvPr/>
-        </p:nvSpPr>
-        <p:spPr>
-          <a:xfrm>
-            <a:off x="3630168" y="1810512"/>
+        <p:txBody>
+          <a:bodyPr/>
+          <a:lstStyle/>
+          <a:p>
+            <a:endParaRPr lang="es-EC" dirty="0"/>
+          </a:p>
+        </p:txBody>
+      </p:sp>
+      <p:sp>
+        <p:nvSpPr>
+          <p:cNvPr id="16" name="Text 14"/>
+          <p:cNvSpPr/>
+          <p:nvPr/>
+        </p:nvSpPr>
+        <p:spPr>
+          <a:xfrm>
+            <a:off x="4361688" y="1810512"/>
             <a:ext cx="457200" cy="457200"/>
           </a:xfrm>
           <a:prstGeom prst="rect">
@@ -8306,14 +8352,7 @@
               <a:buNone/>
             </a:pPr>
             <a:r>
-              <a:rPr lang="en-US" sz="1600" b="1" dirty="0">
-                <a:solidFill>
-                  <a:srgbClr val="1E2761"/>
-                </a:solidFill>
-                <a:latin typeface="Calibri" pitchFamily="34" charset="0"/>
-                <a:ea typeface="Calibri" pitchFamily="34" charset="-122"/>
-                <a:cs typeface="Calibri" pitchFamily="34" charset="-120"/>
-              </a:rPr>
+              <a:rPr lang="en-US" sz="1600"/>
               <a:t>2</a:t>
             </a:r>
             <a:endParaRPr lang="en-US" sz="1600" dirty="0"/>
@@ -8322,13 +8361,13 @@
       </p:sp>
       <p:sp>
         <p:nvSpPr>
-          <p:cNvPr id="12" name="Text 10"/>
-          <p:cNvSpPr/>
-          <p:nvPr/>
-        </p:nvSpPr>
-        <p:spPr>
-          <a:xfrm>
-            <a:off x="3630168" y="2395728"/>
+          <p:cNvPr id="17" name="Text 15"/>
+          <p:cNvSpPr/>
+          <p:nvPr/>
+        </p:nvSpPr>
+        <p:spPr>
+          <a:xfrm>
+            <a:off x="4361688" y="2395728"/>
             <a:ext cx="2286000" cy="548640"/>
           </a:xfrm>
           <a:prstGeom prst="rect">
@@ -8348,7 +8387,7 @@
               <a:buNone/>
             </a:pPr>
             <a:r>
-              <a:rPr lang="en-US" sz="1400" b="1" dirty="0">
+              <a:rPr lang="en-US" sz="1400" b="1">
                 <a:solidFill>
                   <a:srgbClr val="FFFFFF"/>
                 </a:solidFill>
@@ -8356,7 +8395,7 @@
                 <a:ea typeface="Cambria" pitchFamily="34" charset="-122"/>
                 <a:cs typeface="Cambria" pitchFamily="34" charset="-120"/>
               </a:rPr>
-              <a:t>Limitación reconocida</a:t>
+              <a:t>Iteración con feedback</a:t>
             </a:r>
             <a:endParaRPr lang="en-US" sz="1400" dirty="0"/>
           </a:p>
@@ -8364,13 +8403,13 @@
       </p:sp>
       <p:sp>
         <p:nvSpPr>
-          <p:cNvPr id="13" name="Text 11"/>
-          <p:cNvSpPr/>
-          <p:nvPr/>
-        </p:nvSpPr>
-        <p:spPr>
-          <a:xfrm>
-            <a:off x="3630168" y="2944368"/>
+          <p:cNvPr id="18" name="Text 16"/>
+          <p:cNvSpPr/>
+          <p:nvPr/>
+        </p:nvSpPr>
+        <p:spPr>
+          <a:xfrm>
+            <a:off x="4361688" y="2944368"/>
             <a:ext cx="2286000" cy="1188720"/>
           </a:xfrm>
           <a:prstGeom prst="rect">
@@ -8390,7 +8429,7 @@
               <a:buNone/>
             </a:pPr>
             <a:r>
-              <a:rPr lang="en-US" sz="1100" dirty="0">
+              <a:rPr lang="en-US" sz="1100">
                 <a:solidFill>
                   <a:srgbClr val="CADCFC"/>
                 </a:solidFill>
@@ -8398,7 +8437,7 @@
                 <a:ea typeface="Calibri" pitchFamily="34" charset="-122"/>
                 <a:cs typeface="Calibri" pitchFamily="34" charset="-120"/>
               </a:rPr>
-              <a:t>ENEMDU queda fuera del alcance definido para 4.º ciclo.</a:t>
+              <a:t>Semaforización, insights y filtros añadidos tras la revisión del tutor.</a:t>
             </a:r>
             <a:endParaRPr lang="en-US" sz="1100" dirty="0"/>
           </a:p>
@@ -8406,13 +8445,13 @@
       </p:sp>
       <p:sp>
         <p:nvSpPr>
-          <p:cNvPr id="14" name="Shape 12"/>
-          <p:cNvSpPr/>
-          <p:nvPr/>
-        </p:nvSpPr>
-        <p:spPr>
-          <a:xfrm>
-            <a:off x="6309360" y="1600200"/>
+          <p:cNvPr id="19" name="Shape 17"/>
+          <p:cNvSpPr/>
+          <p:nvPr/>
+        </p:nvSpPr>
+        <p:spPr>
+          <a:xfrm>
+            <a:off x="7597142" y="1633086"/>
             <a:ext cx="2697480" cy="2651760"/>
           </a:xfrm>
           <a:prstGeom prst="roundRect">
@@ -8433,13 +8472,13 @@
       </p:sp>
       <p:sp>
         <p:nvSpPr>
-          <p:cNvPr id="15" name="Shape 13"/>
-          <p:cNvSpPr/>
-          <p:nvPr/>
-        </p:nvSpPr>
-        <p:spPr>
-          <a:xfrm>
-            <a:off x="6510528" y="1810512"/>
+          <p:cNvPr id="20" name="Shape 18"/>
+          <p:cNvSpPr/>
+          <p:nvPr/>
+        </p:nvSpPr>
+        <p:spPr>
+          <a:xfrm>
+            <a:off x="7798310" y="1843398"/>
             <a:ext cx="457200" cy="457200"/>
           </a:xfrm>
           <a:prstGeom prst="roundRect">
@@ -8455,13 +8494,13 @@
       </p:sp>
       <p:sp>
         <p:nvSpPr>
-          <p:cNvPr id="16" name="Text 14"/>
-          <p:cNvSpPr/>
-          <p:nvPr/>
-        </p:nvSpPr>
-        <p:spPr>
-          <a:xfrm>
-            <a:off x="6510528" y="1810512"/>
+          <p:cNvPr id="21" name="Text 19"/>
+          <p:cNvSpPr/>
+          <p:nvPr/>
+        </p:nvSpPr>
+        <p:spPr>
+          <a:xfrm>
+            <a:off x="7798310" y="1843398"/>
             <a:ext cx="457200" cy="457200"/>
           </a:xfrm>
           <a:prstGeom prst="rect">
@@ -8494,13 +8533,13 @@
       </p:sp>
       <p:sp>
         <p:nvSpPr>
-          <p:cNvPr id="17" name="Text 15"/>
-          <p:cNvSpPr/>
-          <p:nvPr/>
-        </p:nvSpPr>
-        <p:spPr>
-          <a:xfrm>
-            <a:off x="6510528" y="2395728"/>
+          <p:cNvPr id="22" name="Text 20"/>
+          <p:cNvSpPr/>
+          <p:nvPr/>
+        </p:nvSpPr>
+        <p:spPr>
+          <a:xfrm>
+            <a:off x="7798310" y="2428614"/>
             <a:ext cx="2286000" cy="548640"/>
           </a:xfrm>
           <a:prstGeom prst="rect">
@@ -8528,7 +8567,7 @@
                 <a:ea typeface="Cambria" pitchFamily="34" charset="-122"/>
                 <a:cs typeface="Cambria" pitchFamily="34" charset="-120"/>
               </a:rPr>
-              <a:t>Iteración con feedback</a:t>
+              <a:t>Recomendación</a:t>
             </a:r>
             <a:endParaRPr lang="en-US" sz="1400" dirty="0"/>
           </a:p>
@@ -8536,185 +8575,13 @@
       </p:sp>
       <p:sp>
         <p:nvSpPr>
-          <p:cNvPr id="18" name="Text 16"/>
-          <p:cNvSpPr/>
-          <p:nvPr/>
-        </p:nvSpPr>
-        <p:spPr>
-          <a:xfrm>
-            <a:off x="6510528" y="2944368"/>
-            <a:ext cx="2286000" cy="1188720"/>
-          </a:xfrm>
-          <a:prstGeom prst="rect">
-            <a:avLst/>
-          </a:prstGeom>
-          <a:noFill/>
-          <a:ln/>
-        </p:spPr>
-        <p:txBody>
-          <a:bodyPr wrap="square" rtlCol="0" anchor="ctr"/>
-          <a:lstStyle/>
-          <a:p>
-            <a:pPr marL="0" indent="0">
-              <a:lnSpc>
-                <a:spcPts val="1450"/>
-              </a:lnSpc>
-              <a:buNone/>
-            </a:pPr>
-            <a:r>
-              <a:rPr lang="en-US" sz="1100" dirty="0">
-                <a:solidFill>
-                  <a:srgbClr val="CADCFC"/>
-                </a:solidFill>
-                <a:latin typeface="Calibri" pitchFamily="34" charset="0"/>
-                <a:ea typeface="Calibri" pitchFamily="34" charset="-122"/>
-                <a:cs typeface="Calibri" pitchFamily="34" charset="-120"/>
-              </a:rPr>
-              <a:t>Semaforización, insights y filtros añadidos tras la revisión del tutor.</a:t>
-            </a:r>
-            <a:endParaRPr lang="en-US" sz="1100" dirty="0"/>
-          </a:p>
-        </p:txBody>
-      </p:sp>
-      <p:sp>
-        <p:nvSpPr>
-          <p:cNvPr id="19" name="Shape 17"/>
-          <p:cNvSpPr/>
-          <p:nvPr/>
-        </p:nvSpPr>
-        <p:spPr>
-          <a:xfrm>
-            <a:off x="9189720" y="1600200"/>
-            <a:ext cx="2697480" cy="2651760"/>
-          </a:xfrm>
-          <a:prstGeom prst="roundRect">
-            <a:avLst>
-              <a:gd name="adj" fmla="val 2759"/>
-            </a:avLst>
-          </a:prstGeom>
-          <a:solidFill>
-            <a:srgbClr val="16204F"/>
-          </a:solidFill>
-          <a:ln w="12700">
-            <a:solidFill>
-              <a:srgbClr val="33407A"/>
-            </a:solidFill>
-            <a:prstDash val="solid"/>
-          </a:ln>
-        </p:spPr>
-      </p:sp>
-      <p:sp>
-        <p:nvSpPr>
-          <p:cNvPr id="20" name="Shape 18"/>
-          <p:cNvSpPr/>
-          <p:nvPr/>
-        </p:nvSpPr>
-        <p:spPr>
-          <a:xfrm>
-            <a:off x="9390888" y="1810512"/>
-            <a:ext cx="457200" cy="457200"/>
-          </a:xfrm>
-          <a:prstGeom prst="roundRect">
-            <a:avLst>
-              <a:gd name="adj" fmla="val 50000"/>
-            </a:avLst>
-          </a:prstGeom>
-          <a:solidFill>
-            <a:srgbClr val="D4A017"/>
-          </a:solidFill>
-          <a:ln/>
-        </p:spPr>
-      </p:sp>
-      <p:sp>
-        <p:nvSpPr>
-          <p:cNvPr id="21" name="Text 19"/>
-          <p:cNvSpPr/>
-          <p:nvPr/>
-        </p:nvSpPr>
-        <p:spPr>
-          <a:xfrm>
-            <a:off x="9390888" y="1810512"/>
-            <a:ext cx="457200" cy="457200"/>
-          </a:xfrm>
-          <a:prstGeom prst="rect">
-            <a:avLst/>
-          </a:prstGeom>
-          <a:noFill/>
-          <a:ln/>
-        </p:spPr>
-        <p:txBody>
-          <a:bodyPr wrap="square" rtlCol="0" anchor="ctr"/>
-          <a:lstStyle/>
-          <a:p>
-            <a:pPr marL="0" indent="0" algn="ctr">
-              <a:buNone/>
-            </a:pPr>
-            <a:r>
-              <a:rPr lang="en-US" sz="1600" b="1" dirty="0">
-                <a:solidFill>
-                  <a:srgbClr val="1E2761"/>
-                </a:solidFill>
-                <a:latin typeface="Calibri" pitchFamily="34" charset="0"/>
-                <a:ea typeface="Calibri" pitchFamily="34" charset="-122"/>
-                <a:cs typeface="Calibri" pitchFamily="34" charset="-120"/>
-              </a:rPr>
-              <a:t>4</a:t>
-            </a:r>
-            <a:endParaRPr lang="en-US" sz="1600" dirty="0"/>
-          </a:p>
-        </p:txBody>
-      </p:sp>
-      <p:sp>
-        <p:nvSpPr>
-          <p:cNvPr id="22" name="Text 20"/>
-          <p:cNvSpPr/>
-          <p:nvPr/>
-        </p:nvSpPr>
-        <p:spPr>
-          <a:xfrm>
-            <a:off x="9390888" y="2395728"/>
-            <a:ext cx="2286000" cy="548640"/>
-          </a:xfrm>
-          <a:prstGeom prst="rect">
-            <a:avLst/>
-          </a:prstGeom>
-          <a:noFill/>
-          <a:ln/>
-        </p:spPr>
-        <p:txBody>
-          <a:bodyPr wrap="square" rtlCol="0" anchor="ctr"/>
-          <a:lstStyle/>
-          <a:p>
-            <a:pPr marL="0" indent="0">
-              <a:lnSpc>
-                <a:spcPts val="1700"/>
-              </a:lnSpc>
-              <a:buNone/>
-            </a:pPr>
-            <a:r>
-              <a:rPr lang="en-US" sz="1400" b="1" dirty="0">
-                <a:solidFill>
-                  <a:srgbClr val="FFFFFF"/>
-                </a:solidFill>
-                <a:latin typeface="Cambria" pitchFamily="34" charset="0"/>
-                <a:ea typeface="Cambria" pitchFamily="34" charset="-122"/>
-                <a:cs typeface="Cambria" pitchFamily="34" charset="-120"/>
-              </a:rPr>
-              <a:t>Recomendación</a:t>
-            </a:r>
-            <a:endParaRPr lang="en-US" sz="1400" dirty="0"/>
-          </a:p>
-        </p:txBody>
-      </p:sp>
-      <p:sp>
-        <p:nvSpPr>
           <p:cNvPr id="23" name="Text 21"/>
           <p:cNvSpPr/>
           <p:nvPr/>
         </p:nvSpPr>
         <p:spPr>
           <a:xfrm>
-            <a:off x="9390888" y="2944368"/>
+            <a:off x="7798310" y="2977254"/>
             <a:ext cx="2286000" cy="1188720"/>
           </a:xfrm>
           <a:prstGeom prst="rect">

</xml_diff>